<commit_message>
Point deck and README to the updated presentation video
Co-Authored-By: Claude Sonnet 5.5 <noreply@anthropic.com>
</commit_message>
<xml_diff>
--- a/GP_41_Crypto_Transaction_System.pptx
+++ b/GP_41_Crypto_Transaction_System.pptx
@@ -4684,7 +4684,7 @@
                 </a:solidFill>
                 <a:hlinkClick r:id="rId3"/>
               </a:rPr>
-              <a:t>https://youtu.be/RzAfwPB6Ctg</a:t>
+              <a:t>https://youtu.be/AgEqoAu_OqE</a:t>
             </a:r>
           </a:p>
         </p:txBody>
@@ -8862,7 +8862,7 @@
                   <a:srgbClr val="E9EDF7"/>
                 </a:solidFill>
               </a:rPr>
-              <a:t>Video: youtu.be/RzAfwPB6Ctg</a:t>
+              <a:t>Video: youtu.be/AgEqoAu_OqE</a:t>
             </a:r>
           </a:p>
         </p:txBody>

</xml_diff>

<commit_message>
Show the presentation video and repo as hyperlinked text instead of raw URLs
Co-Authored-By: Claude Sonnet 5.5 <noreply@anthropic.com>
</commit_message>
<xml_diff>
--- a/GP_41_Crypto_Transaction_System.pptx
+++ b/GP_41_Crypto_Transaction_System.pptx
@@ -4684,7 +4684,7 @@
                 </a:solidFill>
                 <a:hlinkClick r:id="rId3"/>
               </a:rPr>
-              <a:t>https://youtu.be/AgEqoAu_OqE</a:t>
+              <a:t>Watch the 3-minute presentation video on YouTube</a:t>
             </a:r>
           </a:p>
         </p:txBody>
@@ -8842,10 +8842,11 @@
               </a:spcAft>
             </a:pPr>
             <a:r>
-              <a:rPr sz="1400" b="0">
-                <a:solidFill>
-                  <a:srgbClr val="E9EDF7"/>
-                </a:solidFill>
+              <a:rPr sz="1400" b="0" u="sng">
+                <a:solidFill>
+                  <a:srgbClr val="6EA8FE"/>
+                </a:solidFill>
+                <a:hlinkClick r:id="rId4"/>
               </a:rPr>
               <a:t>GitHub: TA-rathnayaka/minichain</a:t>
             </a:r>
@@ -8857,12 +8858,13 @@
               </a:spcAft>
             </a:pPr>
             <a:r>
-              <a:rPr sz="1400" b="0">
-                <a:solidFill>
-                  <a:srgbClr val="E9EDF7"/>
-                </a:solidFill>
-              </a:rPr>
-              <a:t>Video: youtu.be/AgEqoAu_OqE</a:t>
+              <a:rPr sz="1400" b="0" u="sng">
+                <a:solidFill>
+                  <a:srgbClr val="6EA8FE"/>
+                </a:solidFill>
+                <a:hlinkClick r:id="rId3"/>
+              </a:rPr>
+              <a:t>Watch the presentation video</a:t>
             </a:r>
           </a:p>
         </p:txBody>

</xml_diff>